<commit_message>
Update cover: fill in member info and course details
Cover now shows a single card for the individual submission (Leonardo
Marsiarelli, RM 555366, 3SIOA) and the course line reads
"FIAP - Fase 5 - Mobile Hybrid App - 02/09/2026", in both the
documentation (Word/PDF) and the presentation (PPTX/PDF).
</commit_message>
<xml_diff>
--- a/docs/Apresentacao_Smart_HAS.pptx
+++ b/docs/Apresentacao_Smart_HAS.pptx
@@ -1826,7 +1826,7 @@
                 <a:ea typeface="Calibri" pitchFamily="34" charset="-122"/>
                 <a:cs typeface="Calibri" pitchFamily="34" charset="-120"/>
               </a:rPr>
-              <a:t>INTEGRANTES DO GRUPO</a:t>
+              <a:t>INTEGRANTE</a:t>
             </a:r>
             <a:endParaRPr lang="en-US" sz="1200" dirty="0"/>
           </a:p>
@@ -1840,12 +1840,12 @@
         </p:nvSpPr>
         <p:spPr>
           <a:xfrm>
-            <a:off x="502920" y="2971800"/>
-            <a:ext cx="2590724" cy="3246120"/>
+            <a:off x="4175608" y="2971800"/>
+            <a:ext cx="3840480" cy="3200400"/>
           </a:xfrm>
           <a:prstGeom prst="roundRect">
             <a:avLst>
-              <a:gd name="adj" fmla="val 3530"/>
+              <a:gd name="adj" fmla="val 3429"/>
             </a:avLst>
           </a:prstGeom>
           <a:solidFill>
@@ -1862,8 +1862,8 @@
         </p:nvSpPr>
         <p:spPr>
           <a:xfrm>
-            <a:off x="1272502" y="3291840"/>
-            <a:ext cx="1051560" cy="1051560"/>
+            <a:off x="5455768" y="3337560"/>
+            <a:ext cx="1280160" cy="1280160"/>
           </a:xfrm>
           <a:prstGeom prst="ellipse">
             <a:avLst/>
@@ -1887,8 +1887,8 @@
         </p:nvSpPr>
         <p:spPr>
           <a:xfrm>
-            <a:off x="1272502" y="3291840"/>
-            <a:ext cx="1051560" cy="1051560"/>
+            <a:off x="5455768" y="3337560"/>
+            <a:ext cx="1280160" cy="1280160"/>
           </a:xfrm>
           <a:prstGeom prst="rect">
             <a:avLst/>
@@ -1904,7 +1904,7 @@
               <a:buNone/>
             </a:pPr>
             <a:r>
-              <a:rPr lang="en-US" sz="1100" dirty="0">
+              <a:rPr lang="en-US" sz="1200" dirty="0">
                 <a:solidFill>
                   <a:srgbClr val="9FB6C9"/>
                 </a:solidFill>
@@ -1914,7 +1914,7 @@
               </a:rPr>
               <a:t>FOTO</a:t>
             </a:r>
-            <a:endParaRPr lang="en-US" sz="1100" dirty="0"/>
+            <a:endParaRPr lang="en-US" sz="1200" dirty="0"/>
           </a:p>
         </p:txBody>
       </p:sp>
@@ -1926,8 +1926,8 @@
         </p:nvSpPr>
         <p:spPr>
           <a:xfrm>
-            <a:off x="612648" y="4480560"/>
-            <a:ext cx="2371268" cy="502920"/>
+            <a:off x="4358488" y="4800600"/>
+            <a:ext cx="3474720" cy="411480"/>
           </a:xfrm>
           <a:prstGeom prst="rect">
             <a:avLst/>
@@ -1943,15 +1943,54 @@
               <a:buNone/>
             </a:pPr>
             <a:r>
-              <a:rPr lang="en-US" sz="1250" b="1" dirty="0">
+              <a:rPr lang="en-US" sz="1600" b="1" dirty="0">
                 <a:solidFill>
                   <a:srgbClr val="FFFFFF"/>
                 </a:solidFill>
-                <a:latin typeface="Calibri" pitchFamily="34" charset="0"/>
-                <a:ea typeface="Calibri" pitchFamily="34" charset="-122"/>
-                <a:cs typeface="Calibri" pitchFamily="34" charset="-120"/>
-              </a:rPr>
-              <a:t>[Nome do integrante 1]</a:t>
+                <a:latin typeface="Cambria" pitchFamily="34" charset="0"/>
+                <a:ea typeface="Cambria" pitchFamily="34" charset="-122"/>
+                <a:cs typeface="Cambria" pitchFamily="34" charset="-120"/>
+              </a:rPr>
+              <a:t>Leonardo Marsiarelli</a:t>
+            </a:r>
+            <a:endParaRPr lang="en-US" sz="1600" dirty="0"/>
+          </a:p>
+        </p:txBody>
+      </p:sp>
+      <p:sp>
+        <p:nvSpPr>
+          <p:cNvPr id="10" name="Text 8"/>
+          <p:cNvSpPr txBox="1"/>
+          <p:nvPr/>
+        </p:nvSpPr>
+        <p:spPr>
+          <a:xfrm>
+            <a:off x="4358488" y="5303520"/>
+            <a:ext cx="3474720" cy="292608"/>
+          </a:xfrm>
+          <a:prstGeom prst="rect">
+            <a:avLst/>
+          </a:prstGeom>
+          <a:noFill/>
+          <a:ln/>
+        </p:spPr>
+        <p:txBody>
+          <a:bodyPr wrap="square" lIns="0" tIns="0" rIns="0" bIns="0" rtlCol="0" anchor="ctr"/>
+          <a:lstStyle/>
+          <a:p>
+            <a:pPr algn="ctr" indent="0" marL="0">
+              <a:buNone/>
+            </a:pPr>
+            <a:r>
+              <a:rPr lang="en-US" sz="1250" dirty="0">
+                <a:solidFill>
+                  <a:srgbClr val="5FB8A6"/>
+                </a:solidFill>
+                <a:latin typeface="Calibri" pitchFamily="34" charset="0"/>
+                <a:ea typeface="Calibri" pitchFamily="34" charset="-122"/>
+                <a:cs typeface="Calibri" pitchFamily="34" charset="-120"/>
+              </a:rPr>
+              <a:t>RM: 555366</a:t>
             </a:r>
             <a:endParaRPr lang="en-US" sz="1250" dirty="0"/>
           </a:p>
@@ -1959,14 +1998,14 @@
       </p:sp>
       <p:sp>
         <p:nvSpPr>
-          <p:cNvPr id="10" name="Text 8"/>
-          <p:cNvSpPr txBox="1"/>
-          <p:nvPr/>
-        </p:nvSpPr>
-        <p:spPr>
-          <a:xfrm>
-            <a:off x="612648" y="5029200"/>
-            <a:ext cx="2371268" cy="274320"/>
+          <p:cNvPr id="11" name="Text 9"/>
+          <p:cNvSpPr txBox="1"/>
+          <p:nvPr/>
+        </p:nvSpPr>
+        <p:spPr>
+          <a:xfrm>
+            <a:off x="4358488" y="5623560"/>
+            <a:ext cx="3474720" cy="292608"/>
           </a:xfrm>
           <a:prstGeom prst="rect">
             <a:avLst/>
@@ -1982,46 +2021,7 @@
               <a:buNone/>
             </a:pPr>
             <a:r>
-              <a:rPr lang="en-US" sz="1100" dirty="0">
-                <a:solidFill>
-                  <a:srgbClr val="5FB8A6"/>
-                </a:solidFill>
-                <a:latin typeface="Calibri" pitchFamily="34" charset="0"/>
-                <a:ea typeface="Calibri" pitchFamily="34" charset="-122"/>
-                <a:cs typeface="Calibri" pitchFamily="34" charset="-120"/>
-              </a:rPr>
-              <a:t>RM: [xxxxxx]</a:t>
-            </a:r>
-            <a:endParaRPr lang="en-US" sz="1100" dirty="0"/>
-          </a:p>
-        </p:txBody>
-      </p:sp>
-      <p:sp>
-        <p:nvSpPr>
-          <p:cNvPr id="11" name="Text 9"/>
-          <p:cNvSpPr txBox="1"/>
-          <p:nvPr/>
-        </p:nvSpPr>
-        <p:spPr>
-          <a:xfrm>
-            <a:off x="612648" y="5330952"/>
-            <a:ext cx="2371268" cy="274320"/>
-          </a:xfrm>
-          <a:prstGeom prst="rect">
-            <a:avLst/>
-          </a:prstGeom>
-          <a:noFill/>
-          <a:ln/>
-        </p:spPr>
-        <p:txBody>
-          <a:bodyPr wrap="square" lIns="0" tIns="0" rIns="0" bIns="0" rtlCol="0" anchor="ctr"/>
-          <a:lstStyle/>
-          <a:p>
-            <a:pPr algn="ctr" indent="0" marL="0">
-              <a:buNone/>
-            </a:pPr>
-            <a:r>
-              <a:rPr lang="en-US" sz="1100" dirty="0">
+              <a:rPr lang="en-US" sz="1250" dirty="0">
                 <a:solidFill>
                   <a:srgbClr val="9FB6C9"/>
                 </a:solidFill>
@@ -2029,132 +2029,7 @@
                 <a:ea typeface="Calibri" pitchFamily="34" charset="-122"/>
                 <a:cs typeface="Calibri" pitchFamily="34" charset="-120"/>
               </a:rPr>
-              <a:t>Turma: [xxxx]</a:t>
-            </a:r>
-            <a:endParaRPr lang="en-US" sz="1100" dirty="0"/>
-          </a:p>
-        </p:txBody>
-      </p:sp>
-      <p:sp>
-        <p:nvSpPr>
-          <p:cNvPr id="12" name="Shape 10"/>
-          <p:cNvSpPr/>
-          <p:nvPr/>
-        </p:nvSpPr>
-        <p:spPr>
-          <a:xfrm>
-            <a:off x="3367964" y="2971800"/>
-            <a:ext cx="2590724" cy="3246120"/>
-          </a:xfrm>
-          <a:prstGeom prst="roundRect">
-            <a:avLst>
-              <a:gd name="adj" fmla="val 3530"/>
-            </a:avLst>
-          </a:prstGeom>
-          <a:solidFill>
-            <a:srgbClr val="24405C"/>
-          </a:solidFill>
-          <a:ln/>
-        </p:spPr>
-      </p:sp>
-      <p:sp>
-        <p:nvSpPr>
-          <p:cNvPr id="13" name="Shape 11"/>
-          <p:cNvSpPr/>
-          <p:nvPr/>
-        </p:nvSpPr>
-        <p:spPr>
-          <a:xfrm>
-            <a:off x="4137546" y="3291840"/>
-            <a:ext cx="1051560" cy="1051560"/>
-          </a:xfrm>
-          <a:prstGeom prst="ellipse">
-            <a:avLst/>
-          </a:prstGeom>
-          <a:solidFill>
-            <a:srgbClr val="34567A"/>
-          </a:solidFill>
-          <a:ln w="19050">
-            <a:solidFill>
-              <a:srgbClr val="5FB8A6"/>
-            </a:solidFill>
-            <a:prstDash val="solid"/>
-          </a:ln>
-        </p:spPr>
-      </p:sp>
-      <p:sp>
-        <p:nvSpPr>
-          <p:cNvPr id="14" name="Text 12"/>
-          <p:cNvSpPr txBox="1"/>
-          <p:nvPr/>
-        </p:nvSpPr>
-        <p:spPr>
-          <a:xfrm>
-            <a:off x="4137546" y="3291840"/>
-            <a:ext cx="1051560" cy="1051560"/>
-          </a:xfrm>
-          <a:prstGeom prst="rect">
-            <a:avLst/>
-          </a:prstGeom>
-          <a:noFill/>
-          <a:ln/>
-        </p:spPr>
-        <p:txBody>
-          <a:bodyPr wrap="square" lIns="0" tIns="0" rIns="0" bIns="0" rtlCol="0" anchor="ctr"/>
-          <a:lstStyle/>
-          <a:p>
-            <a:pPr algn="ctr" indent="0" marL="0">
-              <a:buNone/>
-            </a:pPr>
-            <a:r>
-              <a:rPr lang="en-US" sz="1100" dirty="0">
-                <a:solidFill>
-                  <a:srgbClr val="9FB6C9"/>
-                </a:solidFill>
-                <a:latin typeface="Calibri" pitchFamily="34" charset="0"/>
-                <a:ea typeface="Calibri" pitchFamily="34" charset="-122"/>
-                <a:cs typeface="Calibri" pitchFamily="34" charset="-120"/>
-              </a:rPr>
-              <a:t>FOTO</a:t>
-            </a:r>
-            <a:endParaRPr lang="en-US" sz="1100" dirty="0"/>
-          </a:p>
-        </p:txBody>
-      </p:sp>
-      <p:sp>
-        <p:nvSpPr>
-          <p:cNvPr id="15" name="Text 13"/>
-          <p:cNvSpPr txBox="1"/>
-          <p:nvPr/>
-        </p:nvSpPr>
-        <p:spPr>
-          <a:xfrm>
-            <a:off x="3477692" y="4480560"/>
-            <a:ext cx="2371268" cy="502920"/>
-          </a:xfrm>
-          <a:prstGeom prst="rect">
-            <a:avLst/>
-          </a:prstGeom>
-          <a:noFill/>
-          <a:ln/>
-        </p:spPr>
-        <p:txBody>
-          <a:bodyPr wrap="square" lIns="0" tIns="0" rIns="0" bIns="0" rtlCol="0" anchor="t"/>
-          <a:lstStyle/>
-          <a:p>
-            <a:pPr algn="ctr" indent="0" marL="0">
-              <a:buNone/>
-            </a:pPr>
-            <a:r>
-              <a:rPr lang="en-US" sz="1250" b="1" dirty="0">
-                <a:solidFill>
-                  <a:srgbClr val="FFFFFF"/>
-                </a:solidFill>
-                <a:latin typeface="Calibri" pitchFamily="34" charset="0"/>
-                <a:ea typeface="Calibri" pitchFamily="34" charset="-122"/>
-                <a:cs typeface="Calibri" pitchFamily="34" charset="-120"/>
-              </a:rPr>
-              <a:t>[Nome do integrante 2]</a:t>
+              <a:t>Turma: 3SIOA</a:t>
             </a:r>
             <a:endParaRPr lang="en-US" sz="1250" dirty="0"/>
           </a:p>
@@ -2162,491 +2037,7 @@
       </p:sp>
       <p:sp>
         <p:nvSpPr>
-          <p:cNvPr id="16" name="Text 14"/>
-          <p:cNvSpPr txBox="1"/>
-          <p:nvPr/>
-        </p:nvSpPr>
-        <p:spPr>
-          <a:xfrm>
-            <a:off x="3477692" y="5029200"/>
-            <a:ext cx="2371268" cy="274320"/>
-          </a:xfrm>
-          <a:prstGeom prst="rect">
-            <a:avLst/>
-          </a:prstGeom>
-          <a:noFill/>
-          <a:ln/>
-        </p:spPr>
-        <p:txBody>
-          <a:bodyPr wrap="square" lIns="0" tIns="0" rIns="0" bIns="0" rtlCol="0" anchor="ctr"/>
-          <a:lstStyle/>
-          <a:p>
-            <a:pPr algn="ctr" indent="0" marL="0">
-              <a:buNone/>
-            </a:pPr>
-            <a:r>
-              <a:rPr lang="en-US" sz="1100" dirty="0">
-                <a:solidFill>
-                  <a:srgbClr val="5FB8A6"/>
-                </a:solidFill>
-                <a:latin typeface="Calibri" pitchFamily="34" charset="0"/>
-                <a:ea typeface="Calibri" pitchFamily="34" charset="-122"/>
-                <a:cs typeface="Calibri" pitchFamily="34" charset="-120"/>
-              </a:rPr>
-              <a:t>RM: [xxxxxx]</a:t>
-            </a:r>
-            <a:endParaRPr lang="en-US" sz="1100" dirty="0"/>
-          </a:p>
-        </p:txBody>
-      </p:sp>
-      <p:sp>
-        <p:nvSpPr>
-          <p:cNvPr id="17" name="Text 15"/>
-          <p:cNvSpPr txBox="1"/>
-          <p:nvPr/>
-        </p:nvSpPr>
-        <p:spPr>
-          <a:xfrm>
-            <a:off x="3477692" y="5330952"/>
-            <a:ext cx="2371268" cy="274320"/>
-          </a:xfrm>
-          <a:prstGeom prst="rect">
-            <a:avLst/>
-          </a:prstGeom>
-          <a:noFill/>
-          <a:ln/>
-        </p:spPr>
-        <p:txBody>
-          <a:bodyPr wrap="square" lIns="0" tIns="0" rIns="0" bIns="0" rtlCol="0" anchor="ctr"/>
-          <a:lstStyle/>
-          <a:p>
-            <a:pPr algn="ctr" indent="0" marL="0">
-              <a:buNone/>
-            </a:pPr>
-            <a:r>
-              <a:rPr lang="en-US" sz="1100" dirty="0">
-                <a:solidFill>
-                  <a:srgbClr val="9FB6C9"/>
-                </a:solidFill>
-                <a:latin typeface="Calibri" pitchFamily="34" charset="0"/>
-                <a:ea typeface="Calibri" pitchFamily="34" charset="-122"/>
-                <a:cs typeface="Calibri" pitchFamily="34" charset="-120"/>
-              </a:rPr>
-              <a:t>Turma: [xxxx]</a:t>
-            </a:r>
-            <a:endParaRPr lang="en-US" sz="1100" dirty="0"/>
-          </a:p>
-        </p:txBody>
-      </p:sp>
-      <p:sp>
-        <p:nvSpPr>
-          <p:cNvPr id="18" name="Shape 16"/>
-          <p:cNvSpPr/>
-          <p:nvPr/>
-        </p:nvSpPr>
-        <p:spPr>
-          <a:xfrm>
-            <a:off x="6233008" y="2971800"/>
-            <a:ext cx="2590724" cy="3246120"/>
-          </a:xfrm>
-          <a:prstGeom prst="roundRect">
-            <a:avLst>
-              <a:gd name="adj" fmla="val 3530"/>
-            </a:avLst>
-          </a:prstGeom>
-          <a:solidFill>
-            <a:srgbClr val="24405C"/>
-          </a:solidFill>
-          <a:ln/>
-        </p:spPr>
-      </p:sp>
-      <p:sp>
-        <p:nvSpPr>
-          <p:cNvPr id="19" name="Shape 17"/>
-          <p:cNvSpPr/>
-          <p:nvPr/>
-        </p:nvSpPr>
-        <p:spPr>
-          <a:xfrm>
-            <a:off x="7002590" y="3291840"/>
-            <a:ext cx="1051560" cy="1051560"/>
-          </a:xfrm>
-          <a:prstGeom prst="ellipse">
-            <a:avLst/>
-          </a:prstGeom>
-          <a:solidFill>
-            <a:srgbClr val="34567A"/>
-          </a:solidFill>
-          <a:ln w="19050">
-            <a:solidFill>
-              <a:srgbClr val="5FB8A6"/>
-            </a:solidFill>
-            <a:prstDash val="solid"/>
-          </a:ln>
-        </p:spPr>
-      </p:sp>
-      <p:sp>
-        <p:nvSpPr>
-          <p:cNvPr id="20" name="Text 18"/>
-          <p:cNvSpPr txBox="1"/>
-          <p:nvPr/>
-        </p:nvSpPr>
-        <p:spPr>
-          <a:xfrm>
-            <a:off x="7002590" y="3291840"/>
-            <a:ext cx="1051560" cy="1051560"/>
-          </a:xfrm>
-          <a:prstGeom prst="rect">
-            <a:avLst/>
-          </a:prstGeom>
-          <a:noFill/>
-          <a:ln/>
-        </p:spPr>
-        <p:txBody>
-          <a:bodyPr wrap="square" lIns="0" tIns="0" rIns="0" bIns="0" rtlCol="0" anchor="ctr"/>
-          <a:lstStyle/>
-          <a:p>
-            <a:pPr algn="ctr" indent="0" marL="0">
-              <a:buNone/>
-            </a:pPr>
-            <a:r>
-              <a:rPr lang="en-US" sz="1100" dirty="0">
-                <a:solidFill>
-                  <a:srgbClr val="9FB6C9"/>
-                </a:solidFill>
-                <a:latin typeface="Calibri" pitchFamily="34" charset="0"/>
-                <a:ea typeface="Calibri" pitchFamily="34" charset="-122"/>
-                <a:cs typeface="Calibri" pitchFamily="34" charset="-120"/>
-              </a:rPr>
-              <a:t>FOTO</a:t>
-            </a:r>
-            <a:endParaRPr lang="en-US" sz="1100" dirty="0"/>
-          </a:p>
-        </p:txBody>
-      </p:sp>
-      <p:sp>
-        <p:nvSpPr>
-          <p:cNvPr id="21" name="Text 19"/>
-          <p:cNvSpPr txBox="1"/>
-          <p:nvPr/>
-        </p:nvSpPr>
-        <p:spPr>
-          <a:xfrm>
-            <a:off x="6342736" y="4480560"/>
-            <a:ext cx="2371268" cy="502920"/>
-          </a:xfrm>
-          <a:prstGeom prst="rect">
-            <a:avLst/>
-          </a:prstGeom>
-          <a:noFill/>
-          <a:ln/>
-        </p:spPr>
-        <p:txBody>
-          <a:bodyPr wrap="square" lIns="0" tIns="0" rIns="0" bIns="0" rtlCol="0" anchor="t"/>
-          <a:lstStyle/>
-          <a:p>
-            <a:pPr algn="ctr" indent="0" marL="0">
-              <a:buNone/>
-            </a:pPr>
-            <a:r>
-              <a:rPr lang="en-US" sz="1250" b="1" dirty="0">
-                <a:solidFill>
-                  <a:srgbClr val="FFFFFF"/>
-                </a:solidFill>
-                <a:latin typeface="Calibri" pitchFamily="34" charset="0"/>
-                <a:ea typeface="Calibri" pitchFamily="34" charset="-122"/>
-                <a:cs typeface="Calibri" pitchFamily="34" charset="-120"/>
-              </a:rPr>
-              <a:t>[Nome do integrante 3]</a:t>
-            </a:r>
-            <a:endParaRPr lang="en-US" sz="1250" dirty="0"/>
-          </a:p>
-        </p:txBody>
-      </p:sp>
-      <p:sp>
-        <p:nvSpPr>
-          <p:cNvPr id="22" name="Text 20"/>
-          <p:cNvSpPr txBox="1"/>
-          <p:nvPr/>
-        </p:nvSpPr>
-        <p:spPr>
-          <a:xfrm>
-            <a:off x="6342736" y="5029200"/>
-            <a:ext cx="2371268" cy="274320"/>
-          </a:xfrm>
-          <a:prstGeom prst="rect">
-            <a:avLst/>
-          </a:prstGeom>
-          <a:noFill/>
-          <a:ln/>
-        </p:spPr>
-        <p:txBody>
-          <a:bodyPr wrap="square" lIns="0" tIns="0" rIns="0" bIns="0" rtlCol="0" anchor="ctr"/>
-          <a:lstStyle/>
-          <a:p>
-            <a:pPr algn="ctr" indent="0" marL="0">
-              <a:buNone/>
-            </a:pPr>
-            <a:r>
-              <a:rPr lang="en-US" sz="1100" dirty="0">
-                <a:solidFill>
-                  <a:srgbClr val="5FB8A6"/>
-                </a:solidFill>
-                <a:latin typeface="Calibri" pitchFamily="34" charset="0"/>
-                <a:ea typeface="Calibri" pitchFamily="34" charset="-122"/>
-                <a:cs typeface="Calibri" pitchFamily="34" charset="-120"/>
-              </a:rPr>
-              <a:t>RM: [xxxxxx]</a:t>
-            </a:r>
-            <a:endParaRPr lang="en-US" sz="1100" dirty="0"/>
-          </a:p>
-        </p:txBody>
-      </p:sp>
-      <p:sp>
-        <p:nvSpPr>
-          <p:cNvPr id="23" name="Text 21"/>
-          <p:cNvSpPr txBox="1"/>
-          <p:nvPr/>
-        </p:nvSpPr>
-        <p:spPr>
-          <a:xfrm>
-            <a:off x="6342736" y="5330952"/>
-            <a:ext cx="2371268" cy="274320"/>
-          </a:xfrm>
-          <a:prstGeom prst="rect">
-            <a:avLst/>
-          </a:prstGeom>
-          <a:noFill/>
-          <a:ln/>
-        </p:spPr>
-        <p:txBody>
-          <a:bodyPr wrap="square" lIns="0" tIns="0" rIns="0" bIns="0" rtlCol="0" anchor="ctr"/>
-          <a:lstStyle/>
-          <a:p>
-            <a:pPr algn="ctr" indent="0" marL="0">
-              <a:buNone/>
-            </a:pPr>
-            <a:r>
-              <a:rPr lang="en-US" sz="1100" dirty="0">
-                <a:solidFill>
-                  <a:srgbClr val="9FB6C9"/>
-                </a:solidFill>
-                <a:latin typeface="Calibri" pitchFamily="34" charset="0"/>
-                <a:ea typeface="Calibri" pitchFamily="34" charset="-122"/>
-                <a:cs typeface="Calibri" pitchFamily="34" charset="-120"/>
-              </a:rPr>
-              <a:t>Turma: [xxxx]</a:t>
-            </a:r>
-            <a:endParaRPr lang="en-US" sz="1100" dirty="0"/>
-          </a:p>
-        </p:txBody>
-      </p:sp>
-      <p:sp>
-        <p:nvSpPr>
-          <p:cNvPr id="24" name="Shape 22"/>
-          <p:cNvSpPr/>
-          <p:nvPr/>
-        </p:nvSpPr>
-        <p:spPr>
-          <a:xfrm>
-            <a:off x="9098051" y="2971800"/>
-            <a:ext cx="2590724" cy="3246120"/>
-          </a:xfrm>
-          <a:prstGeom prst="roundRect">
-            <a:avLst>
-              <a:gd name="adj" fmla="val 3530"/>
-            </a:avLst>
-          </a:prstGeom>
-          <a:solidFill>
-            <a:srgbClr val="24405C"/>
-          </a:solidFill>
-          <a:ln/>
-        </p:spPr>
-      </p:sp>
-      <p:sp>
-        <p:nvSpPr>
-          <p:cNvPr id="25" name="Shape 23"/>
-          <p:cNvSpPr/>
-          <p:nvPr/>
-        </p:nvSpPr>
-        <p:spPr>
-          <a:xfrm>
-            <a:off x="9867633" y="3291840"/>
-            <a:ext cx="1051560" cy="1051560"/>
-          </a:xfrm>
-          <a:prstGeom prst="ellipse">
-            <a:avLst/>
-          </a:prstGeom>
-          <a:solidFill>
-            <a:srgbClr val="34567A"/>
-          </a:solidFill>
-          <a:ln w="19050">
-            <a:solidFill>
-              <a:srgbClr val="5FB8A6"/>
-            </a:solidFill>
-            <a:prstDash val="solid"/>
-          </a:ln>
-        </p:spPr>
-      </p:sp>
-      <p:sp>
-        <p:nvSpPr>
-          <p:cNvPr id="26" name="Text 24"/>
-          <p:cNvSpPr txBox="1"/>
-          <p:nvPr/>
-        </p:nvSpPr>
-        <p:spPr>
-          <a:xfrm>
-            <a:off x="9867633" y="3291840"/>
-            <a:ext cx="1051560" cy="1051560"/>
-          </a:xfrm>
-          <a:prstGeom prst="rect">
-            <a:avLst/>
-          </a:prstGeom>
-          <a:noFill/>
-          <a:ln/>
-        </p:spPr>
-        <p:txBody>
-          <a:bodyPr wrap="square" lIns="0" tIns="0" rIns="0" bIns="0" rtlCol="0" anchor="ctr"/>
-          <a:lstStyle/>
-          <a:p>
-            <a:pPr algn="ctr" indent="0" marL="0">
-              <a:buNone/>
-            </a:pPr>
-            <a:r>
-              <a:rPr lang="en-US" sz="1100" dirty="0">
-                <a:solidFill>
-                  <a:srgbClr val="9FB6C9"/>
-                </a:solidFill>
-                <a:latin typeface="Calibri" pitchFamily="34" charset="0"/>
-                <a:ea typeface="Calibri" pitchFamily="34" charset="-122"/>
-                <a:cs typeface="Calibri" pitchFamily="34" charset="-120"/>
-              </a:rPr>
-              <a:t>FOTO</a:t>
-            </a:r>
-            <a:endParaRPr lang="en-US" sz="1100" dirty="0"/>
-          </a:p>
-        </p:txBody>
-      </p:sp>
-      <p:sp>
-        <p:nvSpPr>
-          <p:cNvPr id="27" name="Text 25"/>
-          <p:cNvSpPr txBox="1"/>
-          <p:nvPr/>
-        </p:nvSpPr>
-        <p:spPr>
-          <a:xfrm>
-            <a:off x="9207779" y="4480560"/>
-            <a:ext cx="2371268" cy="502920"/>
-          </a:xfrm>
-          <a:prstGeom prst="rect">
-            <a:avLst/>
-          </a:prstGeom>
-          <a:noFill/>
-          <a:ln/>
-        </p:spPr>
-        <p:txBody>
-          <a:bodyPr wrap="square" lIns="0" tIns="0" rIns="0" bIns="0" rtlCol="0" anchor="t"/>
-          <a:lstStyle/>
-          <a:p>
-            <a:pPr algn="ctr" indent="0" marL="0">
-              <a:buNone/>
-            </a:pPr>
-            <a:r>
-              <a:rPr lang="en-US" sz="1250" b="1" dirty="0">
-                <a:solidFill>
-                  <a:srgbClr val="FFFFFF"/>
-                </a:solidFill>
-                <a:latin typeface="Calibri" pitchFamily="34" charset="0"/>
-                <a:ea typeface="Calibri" pitchFamily="34" charset="-122"/>
-                <a:cs typeface="Calibri" pitchFamily="34" charset="-120"/>
-              </a:rPr>
-              <a:t>[Nome do integrante 4]</a:t>
-            </a:r>
-            <a:endParaRPr lang="en-US" sz="1250" dirty="0"/>
-          </a:p>
-        </p:txBody>
-      </p:sp>
-      <p:sp>
-        <p:nvSpPr>
-          <p:cNvPr id="28" name="Text 26"/>
-          <p:cNvSpPr txBox="1"/>
-          <p:nvPr/>
-        </p:nvSpPr>
-        <p:spPr>
-          <a:xfrm>
-            <a:off x="9207779" y="5029200"/>
-            <a:ext cx="2371268" cy="274320"/>
-          </a:xfrm>
-          <a:prstGeom prst="rect">
-            <a:avLst/>
-          </a:prstGeom>
-          <a:noFill/>
-          <a:ln/>
-        </p:spPr>
-        <p:txBody>
-          <a:bodyPr wrap="square" lIns="0" tIns="0" rIns="0" bIns="0" rtlCol="0" anchor="ctr"/>
-          <a:lstStyle/>
-          <a:p>
-            <a:pPr algn="ctr" indent="0" marL="0">
-              <a:buNone/>
-            </a:pPr>
-            <a:r>
-              <a:rPr lang="en-US" sz="1100" dirty="0">
-                <a:solidFill>
-                  <a:srgbClr val="5FB8A6"/>
-                </a:solidFill>
-                <a:latin typeface="Calibri" pitchFamily="34" charset="0"/>
-                <a:ea typeface="Calibri" pitchFamily="34" charset="-122"/>
-                <a:cs typeface="Calibri" pitchFamily="34" charset="-120"/>
-              </a:rPr>
-              <a:t>RM: [xxxxxx]</a:t>
-            </a:r>
-            <a:endParaRPr lang="en-US" sz="1100" dirty="0"/>
-          </a:p>
-        </p:txBody>
-      </p:sp>
-      <p:sp>
-        <p:nvSpPr>
-          <p:cNvPr id="29" name="Text 27"/>
-          <p:cNvSpPr txBox="1"/>
-          <p:nvPr/>
-        </p:nvSpPr>
-        <p:spPr>
-          <a:xfrm>
-            <a:off x="9207779" y="5330952"/>
-            <a:ext cx="2371268" cy="274320"/>
-          </a:xfrm>
-          <a:prstGeom prst="rect">
-            <a:avLst/>
-          </a:prstGeom>
-          <a:noFill/>
-          <a:ln/>
-        </p:spPr>
-        <p:txBody>
-          <a:bodyPr wrap="square" lIns="0" tIns="0" rIns="0" bIns="0" rtlCol="0" anchor="ctr"/>
-          <a:lstStyle/>
-          <a:p>
-            <a:pPr algn="ctr" indent="0" marL="0">
-              <a:buNone/>
-            </a:pPr>
-            <a:r>
-              <a:rPr lang="en-US" sz="1100" dirty="0">
-                <a:solidFill>
-                  <a:srgbClr val="9FB6C9"/>
-                </a:solidFill>
-                <a:latin typeface="Calibri" pitchFamily="34" charset="0"/>
-                <a:ea typeface="Calibri" pitchFamily="34" charset="-122"/>
-                <a:cs typeface="Calibri" pitchFamily="34" charset="-120"/>
-              </a:rPr>
-              <a:t>Turma: [xxxx]</a:t>
-            </a:r>
-            <a:endParaRPr lang="en-US" sz="1100" dirty="0"/>
-          </a:p>
-        </p:txBody>
-      </p:sp>
-      <p:sp>
-        <p:nvSpPr>
-          <p:cNvPr id="30" name="Text 28"/>
+          <p:cNvPr id="12" name="Text 10"/>
           <p:cNvSpPr txBox="1"/>
           <p:nvPr/>
         </p:nvSpPr>
@@ -2677,7 +2068,7 @@
                 <a:ea typeface="Calibri" pitchFamily="34" charset="-122"/>
                 <a:cs typeface="Calibri" pitchFamily="34" charset="-120"/>
               </a:rPr>
-              <a:t>FIAP  ·  [Nome da Disciplina / Fase]  ·  [Data]</a:t>
+              <a:t>FIAP  ·  Fase 5 - Mobile Hybrid App  ·  02/09/2026</a:t>
             </a:r>
             <a:endParaRPr lang="en-US" sz="1000" dirty="0"/>
           </a:p>

</xml_diff>